<commit_message>
feat(agentic): complete time-constraint reasoning & explainable multi-agent study workflow
</commit_message>
<xml_diff>
--- a/Smart_Study_Reminder_AI_AMD_Hackathon.pptx
+++ b/Smart_Study_Reminder_AI_AMD_Hackathon.pptx
@@ -3195,7 +3195,7 @@
               </a:defRPr>
             </a:pPr>
             <a:r>
-              <a:t>From Static Notes to an Autonomous AI Study Operating System  ·  AMD AI PC Mini-Hackathon</a:t>
+              <a:t>Autonomous AI Study Operating System  ·  AMD AI PC Mini-Hackathon</a:t>
             </a:r>
           </a:p>
           <a:p>
@@ -4231,7 +4231,7 @@
               </a:defRPr>
             </a:pPr>
             <a:r>
-              <a:t>Identify a genuine need inside your college — students waste hours suffering from decision paralysis trying to figure out WHAT to study before exams.</a:t>
+              <a:t>Identify a genuine need inside your college — campus students spend hours deciding WHAT to study before they even start studying.</a:t>
             </a:r>
           </a:p>
         </p:txBody>
@@ -4655,7 +4655,7 @@
                 </a:solidFill>
                 <a:latin typeface="Arial"/>
               </a:rPr>
-              <a:t>[ Campus students facing dense course materials, overlapping deadlines, and exam schedules. ]</a:t>
+              <a:t>[ Campus students balancing dense course syllabi, lab submissions, and exam dates. ]</a:t>
             </a:r>
           </a:p>
           <a:p>
@@ -4671,7 +4671,7 @@
               </a:defRPr>
             </a:pPr>
             <a:r>
-              <a:t>Why existing tools fail? </a:t>
+              <a:t>Why generic tools fail? </a:t>
             </a:r>
             <a:r>
               <a:rPr sz="1500" b="0">
@@ -4680,7 +4680,7 @@
                 </a:solidFill>
                 <a:latin typeface="Arial"/>
               </a:rPr>
-              <a:t>[ ChatGPT is passive &amp; context-blind. PDF notes are static. Generic reminders are memoryless timers. None understand prerequisite dependencies or Ebbinghaus decay. ]</a:t>
+              <a:t>[ ChatGPT is context-blind &amp; passive. PDF notes are dead text. Generic reminders are memoryless timers. None track prerequisite graphs or Ebbinghaus memory decay. ]</a:t>
             </a:r>
           </a:p>
           <a:p>
@@ -4705,7 +4705,7 @@
                 </a:solidFill>
                 <a:latin typeface="Arial"/>
               </a:rPr>
-              <a:t>[ Students don't need another chatbot that waits for prompts; they need an autonomous AI system that manages their entire study lifecycle. ]</a:t>
+              <a:t>[ Students don't need another chatbot that waits for manual prompts; they need an AI system that reasons over their course load and builds adaptive study plans. ]</a:t>
             </a:r>
           </a:p>
         </p:txBody>
@@ -4779,7 +4779,7 @@
               </a:defRPr>
             </a:pPr>
             <a:r>
-              <a:t>[ hours wasted per student each week suffering from decision paralysis, disorganized revision, and manual schedule planning ]</a:t>
+              <a:t>[ hours lost per student each week in decision paralysis, manual scheduling friction, and unorganized exam revision ]</a:t>
             </a:r>
           </a:p>
           <a:p>
@@ -4795,7 +4795,7 @@
               </a:defRPr>
             </a:pPr>
             <a:r>
-              <a:t>Domain: [ Higher Education / Autonomous AI Study OS ]</a:t>
+              <a:t>Domain: [ Education / Campus Learning ]</a:t>
             </a:r>
           </a:p>
         </p:txBody>
@@ -4984,7 +4984,7 @@
               </a:defRPr>
             </a:pPr>
             <a:r>
-              <a:t>“[ An Autonomous AI Study Operating System where specialized agents collaborate to transform passive PDFs into adaptive, reflection-validated study roadmaps. ]”</a:t>
+              <a:t>“[ An AI Study Operating System where specialized agents reason over course materials to generate adaptive, reflection-validated study roadmaps. ]”</a:t>
             </a:r>
           </a:p>
         </p:txBody>
@@ -5075,7 +5075,7 @@
               </a:defRPr>
             </a:pPr>
             <a:r>
-              <a:t>How one problem flows through specialized agents</a:t>
+              <a:t>Concrete AI reasoning example</a:t>
             </a:r>
           </a:p>
           <a:p>
@@ -5091,7 +5091,7 @@
               </a:defRPr>
             </a:pPr>
             <a:r>
-              <a:t>[ Uploaded PDFs flow sequentially through DocumentAgent (extracts concepts), StrategyAgent (selects exam focus), PlannerAgent (computes priority), and ReflectionAgent (audits feasibility). ]</a:t>
+              <a:t>[ Student has DBMS exam in 3 days with 1 hour available today. DocumentAgent extracts 9 topics. StrategyAgent selects Exam-Focused mode. PlannerAgent scores priority. ReflectionAgent audits 12-hr workload ceiling. ]</a:t>
             </a:r>
           </a:p>
         </p:txBody>
@@ -5198,7 +5198,7 @@
               </a:defRPr>
             </a:pPr>
             <a:r>
-              <a:t>[ Orchestrator autonomously delegates tasks, maintains thread-safe SharedMemoryStore, enforces Ebbinghaus retention math (R=e^(-t/S)*100), and triggers quizzes without prompts. ]</a:t>
+              <a:t>[ Orchestrator automatically loads context from SharedMemoryStore, enforces Ebbinghaus retention math (R=e^(-t/S)*100), and triggers review sessions without manual prompts. ]</a:t>
             </a:r>
           </a:p>
         </p:txBody>
@@ -5305,7 +5305,7 @@
               </a:defRPr>
             </a:pPr>
             <a:r>
-              <a:t>[ Delivers grounded Socratic tutoring with live interactive tools (DBMS SQL Playground, DSA Code Analyzer, Formula Derivation Engine) and zero generic fallbacks. ]</a:t>
+              <a:t>[ Combines 5-factor priority math (0.35U + 0.20W + 0.20I + 0.10E + 0.15R) with grounded Socratic tutoring and interactive subject tools. ]</a:t>
             </a:r>
           </a:p>
         </p:txBody>
@@ -5363,7 +5363,7 @@
               </a:defRPr>
             </a:pPr>
             <a:r>
-              <a:t>[ Product Mockup: Dynamic AI Study OS Workspace featuring Active Swarm Banner &amp; Grounded Tutoring ]</a:t>
+              <a:t>[ Product UI: AI Study OS Dashboard displaying Real-Time Swarm Execution Banner &amp; Adaptive Session Plan ]</a:t>
             </a:r>
           </a:p>
         </p:txBody>
@@ -5574,7 +5574,7 @@
               </a:defRPr>
             </a:pPr>
             <a:r>
-              <a:t>User Goal</a:t>
+              <a:t>User Input</a:t>
             </a:r>
           </a:p>
         </p:txBody>
@@ -5632,7 +5632,7 @@
               </a:defRPr>
             </a:pPr>
             <a:r>
-              <a:t>OrchestratorAgent</a:t>
+              <a:t>Orchestrator</a:t>
             </a:r>
           </a:p>
         </p:txBody>
@@ -5690,7 +5690,7 @@
               </a:defRPr>
             </a:pPr>
             <a:r>
-              <a:t>SharedMemoryStore</a:t>
+              <a:t>Specialized Agents</a:t>
             </a:r>
           </a:p>
         </p:txBody>
@@ -5748,7 +5748,7 @@
               </a:defRPr>
             </a:pPr>
             <a:r>
-              <a:t>Swarm Agents (8)</a:t>
+              <a:t>Shared Memory</a:t>
             </a:r>
           </a:p>
         </p:txBody>
@@ -5806,7 +5806,7 @@
               </a:defRPr>
             </a:pPr>
             <a:r>
-              <a:t>Validated Response</a:t>
+              <a:t>Adapted Response</a:t>
             </a:r>
           </a:p>
         </p:txBody>
@@ -5842,7 +5842,7 @@
               </a:defRPr>
             </a:pPr>
             <a:r>
-              <a:t>[ Clean Event-Driven Architecture: Single Orchestrator Brain delegating to 8 Domain Agents with Typed Pydantic Models ]</a:t>
+              <a:t>[ System Flow: Orchestrator passes goal to Document, Strategy, Planner, Reflection, and Tutor agents via Shared Memory ]</a:t>
             </a:r>
           </a:p>
         </p:txBody>
@@ -5959,7 +5959,7 @@
               </a:defRPr>
             </a:pPr>
             <a:r>
-              <a:t>[ AMD AI PC (Ryzen AI / ROCm) &amp; LocalAIService / FastAPI AI Microservice (Port 8001) ]</a:t>
+              <a:t>[ AMD AI PC (Ryzen AI / ROCm) &amp; LocalAIService / FastAPI Microservice (Port 8001) ]</a:t>
             </a:r>
           </a:p>
         </p:txBody>
@@ -6558,7 +6558,7 @@
             </a:r>
             <a:br/>
             <a:r>
-              <a:t>DocumentAgent extracts concepts, formulas, code blocks, and prerequisite edges.</a:t>
+              <a:t>DocumentAgent parses 9 chapters, formulas, code snippets, and prerequisite edges.</a:t>
             </a:r>
           </a:p>
         </p:txBody>
@@ -6649,11 +6649,11 @@
               </a:defRPr>
             </a:pPr>
             <a:r>
-              <a:t>[ Reason &amp; Plan (Think) ]</a:t>
+              <a:t>[ Detect Context &amp; Plan (Think) ]</a:t>
             </a:r>
             <a:br/>
             <a:r>
-              <a:t>StrategyAgent selects learning focus; PlannerAgent computes 5-factor priority scores.</a:t>
+              <a:t>StrategyAgent selects Exam-Focused strategy; PlannerAgent computes 5-factor priority scores.</a:t>
             </a:r>
           </a:p>
         </p:txBody>
@@ -6744,11 +6744,11 @@
               </a:defRPr>
             </a:pPr>
             <a:r>
-              <a:t>[ Audit &amp; Reflect (Act) ]</a:t>
+              <a:t>[ Validate Feasibility (Act) ]</a:t>
             </a:r>
             <a:br/>
             <a:r>
-              <a:t>ReflectionAgent validates workload feasibility, caps study at 12 hrs, and prevents burnout.</a:t>
+              <a:t>ReflectionAgent audits schedule, enforces 12-hour ceiling, and adjusts workload.</a:t>
             </a:r>
           </a:p>
         </p:txBody>
@@ -6839,11 +6839,11 @@
               </a:defRPr>
             </a:pPr>
             <a:r>
-              <a:t>[ Adapt &amp; Teach (Observe) ]</a:t>
+              <a:t>[ Grounded Tutoring (Observe) ]</a:t>
             </a:r>
             <a:br/>
             <a:r>
-              <a:t>TutorAgent delivers grounded feedback; LearningAgent updates Ebbinghaus memory decay curve.</a:t>
+              <a:t>TutorAgent evaluates student answer on 6-knob rubric and updates memory retention curve.</a:t>
             </a:r>
           </a:p>
         </p:txBody>
@@ -6879,7 +6879,7 @@
               </a:defRPr>
             </a:pPr>
             <a:r>
-              <a:t>[ End-to-End Intelligent Loop: Document Analysis → Strategy Selection → Priority Math → Feasibility Reflection → Grounded Tutoring ]</a:t>
+              <a:t>[ Complete Student Journey: PDF Import → Graph Extraction → Strategy Selection → Priority Math → Reflection Audit → Grounded Tutoring ]</a:t>
             </a:r>
           </a:p>
         </p:txBody>
@@ -7090,7 +7090,7 @@
               </a:defRPr>
             </a:pPr>
             <a:r>
-              <a:t>[ PDF Upload &amp; Swarm Analysis ]</a:t>
+              <a:t>[ PDF Upload &amp; Graph Extraction ]</a:t>
             </a:r>
           </a:p>
         </p:txBody>
@@ -7126,15 +7126,15 @@
               </a:defRPr>
             </a:pPr>
             <a:r>
-              <a:t>[ What Happened: DocumentAgent extracted 9 chapters.</a:t>
+              <a:t>[ Input: JNTU IQTA PDF uploaded.</a:t>
             </a:r>
             <a:br/>
             <a:r>
-              <a:t>Why AI Chose This: StrategyAgent detected sequential syllabus -&gt; selected Exam-Focused strategy.</a:t>
+              <a:t>AI Decision: DocumentAgent extracts 9 chapters.</a:t>
             </a:r>
             <a:br/>
             <a:r>
-              <a:t>What Changed: Auto-generated knowledge graph without prompts. ]</a:t>
+              <a:t>Output: Knowledge graph cached in SharedMemoryStore. ]</a:t>
             </a:r>
           </a:p>
         </p:txBody>
@@ -7228,15 +7228,15 @@
               </a:defRPr>
             </a:pPr>
             <a:r>
-              <a:t>[ What Happened: PlannerAgent allocated 35-min sessions.</a:t>
+              <a:t>[ Input: User asks 'what should I do now'.</a:t>
             </a:r>
             <a:br/>
             <a:r>
-              <a:t>Why AI Chose This: ReflectionAgent audited workload -&gt; capped daily ceiling at 12 hrs.</a:t>
+              <a:t>AI Decision: StrategyAgent + PlannerAgent calculate priority scores.</a:t>
             </a:r>
             <a:br/>
             <a:r>
-              <a:t>What Changed: Daily roadmap auto-updates in real time. ]</a:t>
+              <a:t>Output: ReflectionAgent validates 35-min study block. ]</a:t>
             </a:r>
           </a:p>
         </p:txBody>
@@ -7294,7 +7294,7 @@
               </a:defRPr>
             </a:pPr>
             <a:r>
-              <a:t>[ Grounded Socratic Tutoring ]</a:t>
+              <a:t>[ Grounded Socratic Tutor ]</a:t>
             </a:r>
           </a:p>
         </p:txBody>
@@ -7330,15 +7330,15 @@
               </a:defRPr>
             </a:pPr>
             <a:r>
-              <a:t>[ What Happened: TutorAgent answered student concept query.</a:t>
+              <a:t>[ Input: Student answers concept query.</a:t>
             </a:r>
             <a:br/>
             <a:r>
-              <a:t>Why AI Chose This: Enforced 6-knob rubric matrix to eliminate hallucinations.</a:t>
+              <a:t>AI Decision: TutorAgent evaluates 6-knob rubric matrix.</a:t>
             </a:r>
             <a:br/>
             <a:r>
-              <a:t>What Changed: Interactive SQL Playground launched automatically. ]</a:t>
+              <a:t>Output: Displays strengths, gaps, and Mermaid diagram. ]</a:t>
             </a:r>
           </a:p>
         </p:txBody>
@@ -7620,7 +7620,7 @@
               </a:defRPr>
             </a:pPr>
             <a:r>
-              <a:t>•  [ Eliminating LLM Hallucinations: Enforcing strict document grounding so the AI tutor never quotes external unverified facts ]</a:t>
+              <a:t>•  [ Grounded Tutoring: Preventing hallucinations by strictly scoping AI responses to extracted document text ]</a:t>
             </a:r>
           </a:p>
           <a:p>
@@ -7636,7 +7636,7 @@
               </a:defRPr>
             </a:pPr>
             <a:r>
-              <a:t>•  [ Thread-Safe Memory Persistence: Maintaining thread-safe SharedMemoryStore state across multi-threaded FastAPI workers ]</a:t>
+              <a:t>•  [ Thread-Safe Shared Memory: Managing state safely across multi-threaded FastAPI workers ]</a:t>
             </a:r>
           </a:p>
           <a:p>
@@ -7652,7 +7652,7 @@
               </a:defRPr>
             </a:pPr>
             <a:r>
-              <a:t>•  [ Real-Time Reflection Guardrails: Building ReflectionAgent to audit schedules and adjust daily workload ceilings dynamically ]</a:t>
+              <a:t>•  [ Reflection Guardrails: Ensuring ReflectionAgent dynamically caps daily study allocations at 12 hours ]</a:t>
             </a:r>
           </a:p>
         </p:txBody>
@@ -7707,7 +7707,7 @@
               </a:defRPr>
             </a:pPr>
             <a:r>
-              <a:t>•  [ Deterministic Scoring + LLM Nuance: Combining 5-factor math (0.35U + 0.20W + 0.20I + 0.10E + 0.15R) with LLM presentation yields fast, reliable planning ]</a:t>
+              <a:t>•  [ Priority Math + LLM Nuance: Combining 5-factor scoring (0.35U + 0.20W + 0.20I + 0.10E + 0.15R) with LLM explanations yields reliable schedules ]</a:t>
             </a:r>
           </a:p>
           <a:p>
@@ -7723,7 +7723,7 @@
               </a:defRPr>
             </a:pPr>
             <a:r>
-              <a:t>•  [ Typed Communication Contracts: Using Pydantic models for inter-agent communication prevents schema drift ]</a:t>
+              <a:t>•  [ Typed Inter-Agent Contracts: Using Pydantic models for communication prevents schema drift between agents ]</a:t>
             </a:r>
           </a:p>
           <a:p>
@@ -7739,7 +7739,7 @@
               </a:defRPr>
             </a:pPr>
             <a:r>
-              <a:t>•  [ Proactive Over Reactive: Shifting from reactive prompt-response to proactive goal-driven agent swarms vastly improves student engagement ]</a:t>
+              <a:t>•  [ Proactive Intelligence: Proactively generating next study actions creates far better UX than waiting for prompts ]</a:t>
             </a:r>
           </a:p>
         </p:txBody>
@@ -7980,7 +7980,7 @@
               </a:defRPr>
             </a:pPr>
             <a:r>
-              <a:t>deterministic priority calculation accuracy</a:t>
+              <a:t>deterministic priority scoring accuracy</a:t>
             </a:r>
           </a:p>
         </p:txBody>
@@ -8032,7 +8032,7 @@
               </a:defRPr>
             </a:pPr>
             <a:r>
-              <a:t>backend test cases passing</a:t>
+              <a:t>backend test suite test cases passing</a:t>
             </a:r>
           </a:p>
         </p:txBody>
@@ -8120,7 +8120,7 @@
               </a:defRPr>
             </a:pPr>
             <a:r>
-              <a:t>[ Fully functional, unit-tested AI Study Operating System running on AMD AI PC with zero legacy fallback loops and zero runtime errors. ]</a:t>
+              <a:t>[ Verified System Outcomes: Grounded PDF knowledge graph extraction, reflection-validated study roadmaps, Ebbinghaus retention tracking, and zero runtime errors on AMD AI PC. ]</a:t>
             </a:r>
           </a:p>
         </p:txBody>

</xml_diff>